<commit_message>
Actualizo datos para reporte
</commit_message>
<xml_diff>
--- a/Reporte 110326.pptx
+++ b/Reporte 110326.pptx
@@ -5,7 +5,7 @@
     <p:sldMasterId id="2147483672" r:id="rId1"/>
   </p:sldMasterIdLst>
   <p:notesMasterIdLst>
-    <p:notesMasterId r:id="rId17"/>
+    <p:notesMasterId r:id="rId18"/>
   </p:notesMasterIdLst>
   <p:sldIdLst>
     <p:sldId id="350" r:id="rId2"/>
@@ -22,23 +22,24 @@
     <p:sldId id="371" r:id="rId13"/>
     <p:sldId id="370" r:id="rId14"/>
     <p:sldId id="379" r:id="rId15"/>
-    <p:sldId id="280" r:id="rId16"/>
+    <p:sldId id="380" r:id="rId16"/>
+    <p:sldId id="280" r:id="rId17"/>
   </p:sldIdLst>
   <p:sldSz cx="9144000" cy="5143500" type="screen16x9"/>
   <p:notesSz cx="6858000" cy="9144000"/>
   <p:embeddedFontLst>
     <p:embeddedFont>
       <p:font typeface="Montserrat" pitchFamily="2" charset="0"/>
-      <p:regular r:id="rId18"/>
-      <p:bold r:id="rId19"/>
-      <p:italic r:id="rId20"/>
-      <p:boldItalic r:id="rId21"/>
+      <p:regular r:id="rId19"/>
+      <p:bold r:id="rId20"/>
+      <p:italic r:id="rId21"/>
+      <p:boldItalic r:id="rId22"/>
     </p:embeddedFont>
     <p:embeddedFont>
       <p:font typeface="Montserrat Black" pitchFamily="2" charset="0"/>
-      <p:bold r:id="rId22"/>
-      <p:italic r:id="rId23"/>
-      <p:boldItalic r:id="rId24"/>
+      <p:bold r:id="rId23"/>
+      <p:italic r:id="rId24"/>
+      <p:boldItalic r:id="rId25"/>
     </p:embeddedFont>
   </p:embeddedFontLst>
   <p:defaultTextStyle>
@@ -6173,10 +6174,10 @@
       </p:sp>
       <p:pic>
         <p:nvPicPr>
-          <p:cNvPr id="3" name="Imagen 2">
+          <p:cNvPr id="4" name="Imagen 3">
             <a:extLst>
               <a:ext uri="{FF2B5EF4-FFF2-40B4-BE49-F238E27FC236}">
-                <a16:creationId xmlns:a16="http://schemas.microsoft.com/office/drawing/2014/main" id="{500F2A4F-7BAF-9FC3-8A5E-9929A72D3CFA}"/>
+                <a16:creationId xmlns:a16="http://schemas.microsoft.com/office/drawing/2014/main" id="{E0BF1F0F-70BE-EA11-36CA-0BCD9911D900}"/>
               </a:ext>
             </a:extLst>
           </p:cNvPr>
@@ -6193,8 +6194,8 @@
         </p:blipFill>
         <p:spPr>
           <a:xfrm>
-            <a:off x="0" y="727625"/>
-            <a:ext cx="9144000" cy="3688250"/>
+            <a:off x="0" y="733206"/>
+            <a:ext cx="9144000" cy="3677088"/>
           </a:xfrm>
           <a:prstGeom prst="rect">
             <a:avLst/>
@@ -6271,10 +6272,10 @@
       </p:sp>
       <p:pic>
         <p:nvPicPr>
-          <p:cNvPr id="4" name="Imagen 3">
+          <p:cNvPr id="5" name="Imagen 4">
             <a:extLst>
               <a:ext uri="{FF2B5EF4-FFF2-40B4-BE49-F238E27FC236}">
-                <a16:creationId xmlns:a16="http://schemas.microsoft.com/office/drawing/2014/main" id="{81C797CC-67B3-C49F-567D-94745CD28C49}"/>
+                <a16:creationId xmlns:a16="http://schemas.microsoft.com/office/drawing/2014/main" id="{E2BE9A5D-E0E5-90ED-CB9D-2028548C0CE6}"/>
               </a:ext>
             </a:extLst>
           </p:cNvPr>
@@ -6291,8 +6292,8 @@
         </p:blipFill>
         <p:spPr>
           <a:xfrm>
-            <a:off x="0" y="830520"/>
-            <a:ext cx="9144000" cy="3482459"/>
+            <a:off x="0" y="861710"/>
+            <a:ext cx="9144000" cy="3420080"/>
           </a:xfrm>
           <a:prstGeom prst="rect">
             <a:avLst/>
@@ -6369,10 +6370,10 @@
       </p:sp>
       <p:pic>
         <p:nvPicPr>
-          <p:cNvPr id="3" name="Imagen 2">
+          <p:cNvPr id="4" name="Imagen 3">
             <a:extLst>
               <a:ext uri="{FF2B5EF4-FFF2-40B4-BE49-F238E27FC236}">
-                <a16:creationId xmlns:a16="http://schemas.microsoft.com/office/drawing/2014/main" id="{260FCF9A-C243-106E-9DD3-8780C6D6E1CB}"/>
+                <a16:creationId xmlns:a16="http://schemas.microsoft.com/office/drawing/2014/main" id="{FD98A8CB-CFAE-9695-3A65-FFCD89C99590}"/>
               </a:ext>
             </a:extLst>
           </p:cNvPr>
@@ -6389,8 +6390,8 @@
         </p:blipFill>
         <p:spPr>
           <a:xfrm>
-            <a:off x="0" y="1215584"/>
-            <a:ext cx="9144000" cy="2712332"/>
+            <a:off x="0" y="1354429"/>
+            <a:ext cx="9144000" cy="2434641"/>
           </a:xfrm>
           <a:prstGeom prst="rect">
             <a:avLst/>
@@ -6467,10 +6468,10 @@
       </p:sp>
       <p:pic>
         <p:nvPicPr>
-          <p:cNvPr id="3" name="Imagen 2">
+          <p:cNvPr id="4" name="Imagen 3">
             <a:extLst>
               <a:ext uri="{FF2B5EF4-FFF2-40B4-BE49-F238E27FC236}">
-                <a16:creationId xmlns:a16="http://schemas.microsoft.com/office/drawing/2014/main" id="{8040DE82-FF8E-8740-8EA6-89B870B74BA9}"/>
+                <a16:creationId xmlns:a16="http://schemas.microsoft.com/office/drawing/2014/main" id="{F02FF624-91D7-7E42-2C7A-B22D061D6CB7}"/>
               </a:ext>
             </a:extLst>
           </p:cNvPr>
@@ -6487,8 +6488,8 @@
         </p:blipFill>
         <p:spPr>
           <a:xfrm>
-            <a:off x="0" y="1368592"/>
-            <a:ext cx="9144000" cy="2406316"/>
+            <a:off x="0" y="1345681"/>
+            <a:ext cx="9144000" cy="2452138"/>
           </a:xfrm>
           <a:prstGeom prst="rect">
             <a:avLst/>
@@ -6571,10 +6572,87 @@
       </p:sp>
       <p:pic>
         <p:nvPicPr>
-          <p:cNvPr id="4" name="Imagen 3">
+          <p:cNvPr id="1026" name="Picture 2">
             <a:extLst>
               <a:ext uri="{FF2B5EF4-FFF2-40B4-BE49-F238E27FC236}">
-                <a16:creationId xmlns:a16="http://schemas.microsoft.com/office/drawing/2014/main" id="{00BD0867-6E1A-BF40-FCDB-A6B530D7AB7C}"/>
+                <a16:creationId xmlns:a16="http://schemas.microsoft.com/office/drawing/2014/main" id="{ADF69307-6B94-33B8-D22C-00D4513CC3C0}"/>
+              </a:ext>
+            </a:extLst>
+          </p:cNvPr>
+          <p:cNvPicPr>
+            <a:picLocks noChangeAspect="1" noChangeArrowheads="1"/>
+          </p:cNvPicPr>
+          <p:nvPr/>
+        </p:nvPicPr>
+        <p:blipFill>
+          <a:blip r:embed="rId2">
+            <a:extLst>
+              <a:ext uri="{28A0092B-C50C-407E-A947-70E740481C1C}">
+                <a14:useLocalDpi xmlns:a14="http://schemas.microsoft.com/office/drawing/2010/main" val="0"/>
+              </a:ext>
+            </a:extLst>
+          </a:blip>
+          <a:srcRect/>
+          <a:stretch>
+            <a:fillRect/>
+          </a:stretch>
+        </p:blipFill>
+        <p:spPr bwMode="auto">
+          <a:xfrm>
+            <a:off x="2090738" y="666750"/>
+            <a:ext cx="4962525" cy="3810000"/>
+          </a:xfrm>
+          <a:prstGeom prst="rect">
+            <a:avLst/>
+          </a:prstGeom>
+          <a:noFill/>
+          <a:extLst>
+            <a:ext uri="{909E8E84-426E-40DD-AFC4-6F175D3DCCD1}">
+              <a14:hiddenFill xmlns:a14="http://schemas.microsoft.com/office/drawing/2010/main">
+                <a:solidFill>
+                  <a:srgbClr val="FFFFFF"/>
+                </a:solidFill>
+              </a14:hiddenFill>
+            </a:ext>
+          </a:extLst>
+        </p:spPr>
+      </p:pic>
+    </p:spTree>
+    <p:extLst>
+      <p:ext uri="{BB962C8B-B14F-4D97-AF65-F5344CB8AC3E}">
+        <p14:creationId xmlns:p14="http://schemas.microsoft.com/office/powerpoint/2010/main" val="3986551415"/>
+      </p:ext>
+    </p:extLst>
+  </p:cSld>
+  <p:clrMapOvr>
+    <a:masterClrMapping/>
+  </p:clrMapOvr>
+</p:sld>
+</file>
+
+<file path=ppt/slides/slide15.xml><?xml version="1.0" encoding="utf-8"?>
+<p:sld xmlns:a="http://schemas.openxmlformats.org/drawingml/2006/main" xmlns:r="http://schemas.openxmlformats.org/officeDocument/2006/relationships" xmlns:p="http://schemas.openxmlformats.org/presentationml/2006/main">
+  <p:cSld>
+    <p:spTree>
+      <p:nvGrpSpPr>
+        <p:cNvPr id="1" name=""/>
+        <p:cNvGrpSpPr/>
+        <p:nvPr/>
+      </p:nvGrpSpPr>
+      <p:grpSpPr>
+        <a:xfrm>
+          <a:off x="0" y="0"/>
+          <a:ext cx="0" cy="0"/>
+          <a:chOff x="0" y="0"/>
+          <a:chExt cx="0" cy="0"/>
+        </a:xfrm>
+      </p:grpSpPr>
+      <p:pic>
+        <p:nvPicPr>
+          <p:cNvPr id="7" name="Imagen 6">
+            <a:extLst>
+              <a:ext uri="{FF2B5EF4-FFF2-40B4-BE49-F238E27FC236}">
+                <a16:creationId xmlns:a16="http://schemas.microsoft.com/office/drawing/2014/main" id="{B8AA6159-06D0-1EE1-8265-4557BB321BF0}"/>
               </a:ext>
             </a:extLst>
           </p:cNvPr>
@@ -6591,8 +6669,8 @@
         </p:blipFill>
         <p:spPr>
           <a:xfrm>
-            <a:off x="1685522" y="337825"/>
-            <a:ext cx="5772956" cy="4467849"/>
+            <a:off x="0" y="756243"/>
+            <a:ext cx="9144000" cy="3631014"/>
           </a:xfrm>
           <a:prstGeom prst="rect">
             <a:avLst/>
@@ -6602,7 +6680,7 @@
     </p:spTree>
     <p:extLst>
       <p:ext uri="{BB962C8B-B14F-4D97-AF65-F5344CB8AC3E}">
-        <p14:creationId xmlns:p14="http://schemas.microsoft.com/office/powerpoint/2010/main" val="3986551415"/>
+        <p14:creationId xmlns:p14="http://schemas.microsoft.com/office/powerpoint/2010/main" val="3352932207"/>
       </p:ext>
     </p:extLst>
   </p:cSld>
@@ -6612,7 +6690,7 @@
 </p:sld>
 </file>
 
-<file path=ppt/slides/slide15.xml><?xml version="1.0" encoding="utf-8"?>
+<file path=ppt/slides/slide16.xml><?xml version="1.0" encoding="utf-8"?>
 <p:sld xmlns:a="http://schemas.openxmlformats.org/drawingml/2006/main" xmlns:r="http://schemas.openxmlformats.org/officeDocument/2006/relationships" xmlns:p="http://schemas.openxmlformats.org/presentationml/2006/main">
   <p:cSld>
     <p:spTree>
@@ -7682,10 +7760,10 @@
       </p:sp>
       <p:pic>
         <p:nvPicPr>
-          <p:cNvPr id="4" name="Imagen 3">
+          <p:cNvPr id="5" name="Imagen 4">
             <a:extLst>
               <a:ext uri="{FF2B5EF4-FFF2-40B4-BE49-F238E27FC236}">
-                <a16:creationId xmlns:a16="http://schemas.microsoft.com/office/drawing/2014/main" id="{9777520B-FC57-D5D1-FC00-5D257116571E}"/>
+                <a16:creationId xmlns:a16="http://schemas.microsoft.com/office/drawing/2014/main" id="{B6EB1AF5-A795-1D83-4D83-D3E4D2B7B015}"/>
               </a:ext>
             </a:extLst>
           </p:cNvPr>
@@ -7702,8 +7780,8 @@
         </p:blipFill>
         <p:spPr>
           <a:xfrm>
-            <a:off x="0" y="405772"/>
-            <a:ext cx="9144000" cy="4474832"/>
+            <a:off x="0" y="525162"/>
+            <a:ext cx="9144000" cy="4093176"/>
           </a:xfrm>
           <a:prstGeom prst="rect">
             <a:avLst/>
@@ -7780,10 +7858,10 @@
       </p:sp>
       <p:pic>
         <p:nvPicPr>
-          <p:cNvPr id="3" name="Imagen 2">
+          <p:cNvPr id="4" name="Imagen 3">
             <a:extLst>
               <a:ext uri="{FF2B5EF4-FFF2-40B4-BE49-F238E27FC236}">
-                <a16:creationId xmlns:a16="http://schemas.microsoft.com/office/drawing/2014/main" id="{0A50C18B-1BB5-9DAE-2162-4526F3DBA95B}"/>
+                <a16:creationId xmlns:a16="http://schemas.microsoft.com/office/drawing/2014/main" id="{BCEC340A-5074-17C7-E9DE-9812AF6884FA}"/>
               </a:ext>
             </a:extLst>
           </p:cNvPr>
@@ -7800,8 +7878,8 @@
         </p:blipFill>
         <p:spPr>
           <a:xfrm>
-            <a:off x="0" y="1006706"/>
-            <a:ext cx="9144000" cy="3272963"/>
+            <a:off x="0" y="959438"/>
+            <a:ext cx="9144000" cy="3224623"/>
           </a:xfrm>
           <a:prstGeom prst="rect">
             <a:avLst/>

</xml_diff>